<commit_message>
Fill candidate metadata, remove dead code, update slide 1 with IIITA details
</commit_message>
<xml_diff>
--- a/docs/presentation.pptx
+++ b/docs/presentation.pptx
@@ -1847,6 +1847,51 @@
           </a:p>
         </p:txBody>
       </p:sp>
+      <p:sp xmlns:a="http://schemas.openxmlformats.org/drawingml/2006/main">
+        <p:nvSpPr>
+          <p:cNvPr id="8" name="TextBox 7"/>
+          <p:cNvSpPr txBox="1"/>
+          <p:nvPr/>
+        </p:nvSpPr>
+        <p:spPr>
+          <a:xfrm>
+            <a:off x="571500" y="5700000"/>
+            <a:ext cx="10858500" cy="500000"/>
+          </a:xfrm>
+          <a:prstGeom prst="rect">
+            <a:avLst/>
+          </a:prstGeom>
+          <a:noFill/>
+        </p:spPr>
+        <p:txBody>
+          <a:bodyPr wrap="square">
+            <a:spAutoFit/>
+          </a:bodyPr>
+          <a:lstStyle/>
+          <a:p>
+            <a:pPr algn="l"/>
+            <a:r>
+              <a:rPr sz="1800" b="0">
+                <a:solidFill>
+                  <a:srgbClr val="2D6895"/>
+                </a:solidFill>
+              </a:rPr>
+              <a:t>Sudhanshu  |  iit2024081@iiita.ac.in  |  IIIT Allahabad</a:t>
+            </a:r>
+          </a:p>
+          <a:p>
+            <a:pPr algn="l"/>
+            <a:r>
+              <a:rPr sz="1400" b="0">
+                <a:solidFill>
+                  <a:srgbClr val="61768F"/>
+                </a:solidFill>
+              </a:rPr>
+              <a:t>S&amp;P Global &amp; Crisil Campus Hackathon 2026</a:t>
+            </a:r>
+          </a:p>
+        </p:txBody>
+      </p:sp>
     </p:spTree>
     <p:extLst>
       <p:ext uri="{BB962C8B-B14F-4D97-AF65-F5344CB8AC3E}">

</xml_diff>